<commit_message>
Usar solo el vocabulario de los apuntes: sin Bolzano, Cardano, semilla ni convergencia lineal/cuadrática
Co-Authored-By: Claude Opus 5.5 <noreply@anthropic.com>
</commit_message>
<xml_diff>
--- a/ENTREGABLES/Presentacion_Rosa_Pastel_Metodos_Numericos.pptx
+++ b/ENTREGABLES/Presentacion_Rosa_Pastel_Metodos_Numericos.pptx
@@ -8175,7 +8175,7 @@
                 </a:solidFill>
                 <a:latin typeface="Plus Jakarta Sans"/>
               </a:rPr>
-              <a:t>Raíces: Bisección (cerrado, segura) vs. Newton-Raphson (abierto, rápido).</a:t>
+              <a:t>Raíces: Bisección (intervalo, confiable) vs. Newton-Raphson (abierto, rápido).</a:t>
             </a:r>
             <a:br>
               <a:rPr b="0" sz="1600" i="0" u="none">
@@ -10073,7 +10073,7 @@
                 </a:solidFill>
                 <a:latin typeface="Plus Jakarta Sans"/>
               </a:rPr>
-              <a:t>Lineal. Requiere cambio de signo. Segura y lenta.</a:t>
+              <a:t>Requiere cambio de signo. Confiable, pero lenta.</a:t>
             </a:r>
           </a:p>
         </p:txBody>
@@ -10108,7 +10108,7 @@
                 </a:solidFill>
                 <a:latin typeface="Plus Jakarta Sans"/>
               </a:rPr>
-              <a:t>Semilla inicial: t₀ = 35 semanas</a:t>
+              <a:t>Valor inicial: t₀ = 35 semanas</a:t>
             </a:r>
             <a:r>
               <a:rPr b="1" sz="1350" i="0" u="none">
@@ -10152,7 +10152,7 @@
                 </a:solidFill>
                 <a:latin typeface="Plus Jakarta Sans"/>
               </a:rPr>
-              <a:t>Cuadrática. Requiere f′(t) y buen t₀. Rápida.</a:t>
+              <a:t>Requiere f′(t) y buen t₀. Rápida.</a:t>
             </a:r>
           </a:p>
         </p:txBody>
@@ -10222,7 +10222,7 @@
                 </a:solidFill>
                 <a:latin typeface="Plus Jakarta Sans"/>
               </a:rPr>
-              <a:t>Cerrado</a:t>
+              <a:t>Intervalo</a:t>
             </a:r>
           </a:p>
         </p:txBody>
@@ -10633,7 +10633,7 @@
                 </a:solidFill>
                 <a:latin typeface="Plus Jakarta Sans"/>
               </a:rPr>
-              <a:t>Newton-Raphson: Convergencia cuadrática en solo 3 pasos.</a:t>
+              <a:t>Newton-Raphson: convergencia rápida, solo 3 pasos.</a:t>
             </a:r>
           </a:p>
         </p:txBody>
@@ -10707,7 +10707,7 @@
                 </a:solidFill>
                 <a:latin typeface="Space Grotesk"/>
               </a:rPr>
-              <a:t>Convergencia: Lineal vs. Cuadrática</a:t>
+              <a:t>Convergencia: Lenta vs. Rápida</a:t>
             </a:r>
           </a:p>
         </p:txBody>

</xml_diff>

<commit_message>
Informe y presentación: sacar la trazadora y las referencias a apartados de los apuntes
Co-Authored-By: Claude Opus 5.5 <noreply@anthropic.com>
</commit_message>
<xml_diff>
--- a/ENTREGABLES/Presentacion_Rosa_Pastel_Metodos_Numericos.pptx
+++ b/ENTREGABLES/Presentacion_Rosa_Pastel_Metodos_Numericos.pptx
@@ -7581,7 +7581,7 @@
         <p:spPr>
           <a:xfrm>
             <a:off x="609600" y="2880270"/>
-            <a:ext cx="2571750" cy="2019300"/>
+            <a:ext cx="3505200" cy="2019300"/>
           </a:xfrm>
           <a:prstGeom prst="roundRect">
             <a:avLst>
@@ -7626,8 +7626,8 @@
         </p:nvSpPr>
         <p:spPr>
           <a:xfrm>
-            <a:off x="3409950" y="2880270"/>
-            <a:ext cx="2571750" cy="2019300"/>
+            <a:off x="4343400" y="2880270"/>
+            <a:ext cx="3505200" cy="2019300"/>
           </a:xfrm>
           <a:prstGeom prst="roundRect">
             <a:avLst>
@@ -7666,14 +7666,14 @@
       </p:sp>
       <p:sp>
         <p:nvSpPr>
-          <p:cNvPr id="4" name="Rounded Rectangle 3"/>
+          <p:cNvPr id="5" name="Rounded Rectangle 4"/>
           <p:cNvSpPr/>
           <p:nvPr/>
         </p:nvSpPr>
         <p:spPr>
           <a:xfrm>
-            <a:off x="6210300" y="2880270"/>
-            <a:ext cx="2571750" cy="2019300"/>
+            <a:off x="8077200" y="2880270"/>
+            <a:ext cx="3505200" cy="2019300"/>
           </a:xfrm>
           <a:prstGeom prst="roundRect">
             <a:avLst>
@@ -7712,52 +7712,6 @@
       </p:sp>
       <p:sp>
         <p:nvSpPr>
-          <p:cNvPr id="5" name="Rounded Rectangle 4"/>
-          <p:cNvSpPr/>
-          <p:nvPr/>
-        </p:nvSpPr>
-        <p:spPr>
-          <a:xfrm>
-            <a:off x="9010650" y="2880270"/>
-            <a:ext cx="2571750" cy="2019300"/>
-          </a:xfrm>
-          <a:prstGeom prst="roundRect">
-            <a:avLst>
-              <a:gd name="adj" fmla="val 7547"/>
-            </a:avLst>
-          </a:prstGeom>
-          <a:solidFill>
-            <a:srgbClr val="F8FAFC"/>
-          </a:solidFill>
-          <a:ln>
-            <a:noFill/>
-          </a:ln>
-          <a:effectLst/>
-        </p:spPr>
-        <p:style>
-          <a:lnRef idx="1">
-            <a:schemeClr val="accent1"/>
-          </a:lnRef>
-          <a:fillRef idx="3">
-            <a:schemeClr val="accent1"/>
-          </a:fillRef>
-          <a:effectRef idx="2">
-            <a:schemeClr val="accent1"/>
-          </a:effectRef>
-          <a:fontRef idx="minor">
-            <a:schemeClr val="lt1"/>
-          </a:fontRef>
-        </p:style>
-        <p:txBody>
-          <a:bodyPr rtlCol="0" anchor="ctr"/>
-          <a:lstStyle/>
-          <a:p>
-            <a:pPr algn="ctr"/>
-          </a:p>
-        </p:txBody>
-      </p:sp>
-      <p:sp>
-        <p:nvSpPr>
           <p:cNvPr id="14" name="TextBox 13"/>
           <p:cNvSpPr txBox="1"/>
           <p:nvPr/>
@@ -7839,7 +7793,7 @@
         <p:spPr>
           <a:xfrm>
             <a:off x="838200" y="3261270"/>
-            <a:ext cx="2194560" cy="219075"/>
+            <a:ext cx="3048000" cy="219075"/>
           </a:xfrm>
           <a:prstGeom prst="rect">
             <a:avLst/>
@@ -7874,7 +7828,7 @@
         <p:spPr>
           <a:xfrm>
             <a:off x="838200" y="3594645"/>
-            <a:ext cx="2209800" cy="768096"/>
+            <a:ext cx="3048000" cy="768096"/>
           </a:xfrm>
           <a:prstGeom prst="rect">
             <a:avLst/>
@@ -7908,8 +7862,8 @@
         </p:nvSpPr>
         <p:spPr>
           <a:xfrm>
-            <a:off x="3638550" y="3261270"/>
-            <a:ext cx="2194560" cy="219075"/>
+            <a:off x="4572000" y="3261270"/>
+            <a:ext cx="3048000" cy="219075"/>
           </a:xfrm>
           <a:prstGeom prst="rect">
             <a:avLst/>
@@ -7930,7 +7884,7 @@
                 </a:solidFill>
                 <a:latin typeface="Space Grotesk"/>
               </a:rPr>
-              <a:t>Lagrange (5.4)</a:t>
+              <a:t>Lagrange</a:t>
             </a:r>
           </a:p>
         </p:txBody>
@@ -7943,8 +7897,8 @@
         </p:nvSpPr>
         <p:spPr>
           <a:xfrm>
-            <a:off x="3638550" y="3594645"/>
-            <a:ext cx="2209800" cy="768096"/>
+            <a:off x="4572000" y="3594645"/>
+            <a:ext cx="3048000" cy="768096"/>
           </a:xfrm>
           <a:prstGeom prst="rect">
             <a:avLst/>
@@ -7972,14 +7926,14 @@
       </p:sp>
       <p:sp>
         <p:nvSpPr>
-          <p:cNvPr id="20" name="TextBox 19"/>
-          <p:cNvSpPr txBox="1"/>
-          <p:nvPr/>
-        </p:nvSpPr>
-        <p:spPr>
-          <a:xfrm>
-            <a:off x="6438900" y="3261270"/>
-            <a:ext cx="2194560" cy="219075"/>
+          <p:cNvPr id="22" name="TextBox 21"/>
+          <p:cNvSpPr txBox="1"/>
+          <p:nvPr/>
+        </p:nvSpPr>
+        <p:spPr>
+          <a:xfrm>
+            <a:off x="8305800" y="3261270"/>
+            <a:ext cx="3048000" cy="219075"/>
           </a:xfrm>
           <a:prstGeom prst="rect">
             <a:avLst/>
@@ -8000,77 +7954,7 @@
                 </a:solidFill>
                 <a:latin typeface="Space Grotesk"/>
               </a:rPr>
-              <a:t>Trazadora cúbica (5.5)</a:t>
-            </a:r>
-          </a:p>
-        </p:txBody>
-      </p:sp>
-      <p:sp>
-        <p:nvSpPr>
-          <p:cNvPr id="21" name="TextBox 20"/>
-          <p:cNvSpPr txBox="1"/>
-          <p:nvPr/>
-        </p:nvSpPr>
-        <p:spPr>
-          <a:xfrm>
-            <a:off x="6438900" y="3594645"/>
-            <a:ext cx="2209800" cy="768096"/>
-          </a:xfrm>
-          <a:prstGeom prst="rect">
-            <a:avLst/>
-          </a:prstGeom>
-          <a:noFill/>
-        </p:spPr>
-        <p:txBody>
-          <a:bodyPr wrap="square" lIns="0" rIns="0" tIns="0" bIns="0" anchor="t">
-            <a:spAutoFit/>
-          </a:bodyPr>
-          <a:lstStyle/>
-          <a:p>
-            <a:pPr algn="l"/>
-            <a:r>
-              <a:rPr b="0" sz="1500" i="0" u="none">
-                <a:solidFill>
-                  <a:srgbClr val="475569"/>
-                </a:solidFill>
-                <a:latin typeface="Plus Jakarta Sans"/>
-              </a:rPr>
-              <a:t>Pensada para muchos puntos: en un tramo corto fuerza curvatura nula en los bordes.</a:t>
-            </a:r>
-          </a:p>
-        </p:txBody>
-      </p:sp>
-      <p:sp>
-        <p:nvSpPr>
-          <p:cNvPr id="22" name="TextBox 21"/>
-          <p:cNvSpPr txBox="1"/>
-          <p:nvPr/>
-        </p:nvSpPr>
-        <p:spPr>
-          <a:xfrm>
-            <a:off x="9239250" y="3261270"/>
-            <a:ext cx="2194560" cy="219075"/>
-          </a:xfrm>
-          <a:prstGeom prst="rect">
-            <a:avLst/>
-          </a:prstGeom>
-          <a:noFill/>
-        </p:spPr>
-        <p:txBody>
-          <a:bodyPr wrap="none" lIns="0" rIns="0" tIns="0" bIns="0" anchor="t">
-            <a:spAutoFit/>
-          </a:bodyPr>
-          <a:lstStyle/>
-          <a:p>
-            <a:pPr algn="l"/>
-            <a:r>
-              <a:rPr b="1" sz="1600" i="0" u="none">
-                <a:solidFill>
-                  <a:srgbClr val="0F172A"/>
-                </a:solidFill>
-                <a:latin typeface="Space Grotesk"/>
-              </a:rPr>
-              <a:t>Regresión (5.2)</a:t>
+              <a:t>Regresión</a:t>
             </a:r>
           </a:p>
         </p:txBody>
@@ -8083,8 +7967,8 @@
         </p:nvSpPr>
         <p:spPr>
           <a:xfrm>
-            <a:off x="9239250" y="3594645"/>
-            <a:ext cx="2209800" cy="768096"/>
+            <a:off x="8305800" y="3594645"/>
+            <a:ext cx="3048000" cy="768096"/>
           </a:xfrm>
           <a:prstGeom prst="rect">
             <a:avLst/>
@@ -8140,7 +8024,7 @@
                 </a:solidFill>
                 <a:latin typeface="Plus Jakarta Sans"/>
               </a:rPr>
-              <a:t>Se eligió la interpolación de Newton (apartado 5.3) frente a las otras opciones de los apuntes:</a:t>
+              <a:t>Se eligió la interpolación de Newton frente a las otras opciones de los apuntes:</a:t>
             </a:r>
           </a:p>
         </p:txBody>

</xml_diff>